<commit_message>
Extend dashboard: country deep-dives, exposure calculator, DE/EN, present mode
- Country deep-dive tabs for Germany, France, UK and the Nordics
  (adoption, AI hiring, worker attitudes, exposure, labour law, policy)
- Exposure calculator: job function x industry x market -> estimated
  task exposure, augmentation/automation split, recommended moves
- German/English language toggle across all content
- Present mode (section-per-screen, keyboard navigation)
- Cross-links to the Slides deck; PPTX closing slide links the dashboard
- Research notes addendum with country and calculator sources

Co-Authored-By: Claude Fable 5.1 <noreply@anthropic.com>
Claude-Session: https://claude.ai/code/session_01246PDYEha88gx2jEyPhf1Y
</commit_message>
<xml_diff>
--- a/mercer_ai_deck/Mercer_AI_Impact_Careers_Europe.pptx
+++ b/mercer_ai_deck/Mercer_AI_Impact_Careers_Europe.pptx
@@ -3381,7 +3381,7 @@
                 </a:solidFill>
                 <a:latin typeface="Calibri"/>
               </a:rPr>
-              <a:t>Executive briefing  ·  June 2026  ·  Mercer Career — Europe</a:t>
+              <a:t>Executive briefing  ·  September 2026  ·  Mercer Career — Europe</a:t>
             </a:r>
           </a:p>
         </p:txBody>
@@ -5430,6 +5430,41 @@
       <p:sp>
         <p:nvSpPr>
           <p:cNvPr id="7" name="TextBox 6"/>
+          <p:cNvSpPr txBox="1"/>
+          <p:nvPr/>
+        </p:nvSpPr>
+        <p:spPr>
+          <a:xfrm>
+            <a:off x="822960" y="4343400"/>
+            <a:ext cx="10058400" cy="457200"/>
+          </a:xfrm>
+          <a:prstGeom prst="rect">
+            <a:avLst/>
+          </a:prstGeom>
+          <a:noFill/>
+        </p:spPr>
+        <p:txBody>
+          <a:bodyPr wrap="square" anchor="t" lIns="0" rIns="0" tIns="0" bIns="0">
+            <a:spAutoFit/>
+          </a:bodyPr>
+          <a:lstStyle/>
+          <a:p>
+            <a:pPr algn="l"/>
+            <a:r>
+              <a:rPr sz="1100" b="0" i="0">
+                <a:solidFill>
+                  <a:srgbClr val="00A8C7"/>
+                </a:solidFill>
+                <a:latin typeface="Calibri"/>
+              </a:rPr>
+              <a:t>Interactive dashboard (country deep-dives, exposure calculator): https://claude.ai/artifact/MciK1Nwww1SaWMzM1eJrWK</a:t>
+            </a:r>
+          </a:p>
+        </p:txBody>
+      </p:sp>
+      <p:sp>
+        <p:nvSpPr>
+          <p:cNvPr id="8" name="TextBox 7"/>
           <p:cNvSpPr txBox="1"/>
           <p:nvPr/>
         </p:nvSpPr>

</xml_diff>